<commit_message>
Record verified AWS teardown and finalize recovery case study
</commit_message>
<xml_diff>
--- a/docs/presentation/Northstar-Repairs-Case-Study.pptx
+++ b/docs/presentation/Northstar-Repairs-Case-Study.pptx
@@ -2,23 +2,23 @@
 <file path=ppt/presentation.xml><?xml version="1.0" encoding="utf-8"?>
 <p:presentation xmlns:p="http://schemas.openxmlformats.org/presentationml/2006/main">
   <p:sldMasterIdLst>
-    <p:sldMasterId xmlns:r="http://schemas.openxmlformats.org/officeDocument/2006/relationships" id="2147483648" r:id="R42a29354d24e4fd0"/>
+    <p:sldMasterId xmlns:r="http://schemas.openxmlformats.org/officeDocument/2006/relationships" id="2147483648" r:id="Rba49c1ad88e641c3"/>
   </p:sldMasterIdLst>
   <p:notesMasterIdLst>
-    <p:notesMasterId xmlns:r="http://schemas.openxmlformats.org/officeDocument/2006/relationships" r:id="Rbad062206542438e"/>
+    <p:notesMasterId xmlns:r="http://schemas.openxmlformats.org/officeDocument/2006/relationships" r:id="R6b8f13f329eb4d4d"/>
   </p:notesMasterIdLst>
   <p:sldIdLst>
-    <p:sldId xmlns:r="http://schemas.openxmlformats.org/officeDocument/2006/relationships" id="256" r:id="Rdb28c01473264d89"/>
-    <p:sldId xmlns:r="http://schemas.openxmlformats.org/officeDocument/2006/relationships" id="257" r:id="R3f3ec367e44645ce"/>
-    <p:sldId xmlns:r="http://schemas.openxmlformats.org/officeDocument/2006/relationships" id="258" r:id="Ree40b4f29db24996"/>
-    <p:sldId xmlns:r="http://schemas.openxmlformats.org/officeDocument/2006/relationships" id="259" r:id="R191e95d2edcf49e9"/>
-    <p:sldId xmlns:r="http://schemas.openxmlformats.org/officeDocument/2006/relationships" id="260" r:id="R9d494a7d15824bcf"/>
-    <p:sldId xmlns:r="http://schemas.openxmlformats.org/officeDocument/2006/relationships" id="261" r:id="Rbf17dc985c3249bf"/>
-    <p:sldId xmlns:r="http://schemas.openxmlformats.org/officeDocument/2006/relationships" id="262" r:id="Rcbd5445651b44c10"/>
-    <p:sldId xmlns:r="http://schemas.openxmlformats.org/officeDocument/2006/relationships" id="263" r:id="R8f04f27309e54e9c"/>
-    <p:sldId xmlns:r="http://schemas.openxmlformats.org/officeDocument/2006/relationships" id="264" r:id="Rb823b2cf41ea442c"/>
-    <p:sldId xmlns:r="http://schemas.openxmlformats.org/officeDocument/2006/relationships" id="265" r:id="Re1d1da3c83414cf4"/>
-    <p:sldId xmlns:r="http://schemas.openxmlformats.org/officeDocument/2006/relationships" id="266" r:id="R828047381bc74fd4"/>
+    <p:sldId xmlns:r="http://schemas.openxmlformats.org/officeDocument/2006/relationships" id="256" r:id="R626186f914354ba0"/>
+    <p:sldId xmlns:r="http://schemas.openxmlformats.org/officeDocument/2006/relationships" id="257" r:id="R137b3d15a9e64074"/>
+    <p:sldId xmlns:r="http://schemas.openxmlformats.org/officeDocument/2006/relationships" id="258" r:id="Rc2669c05e9364d02"/>
+    <p:sldId xmlns:r="http://schemas.openxmlformats.org/officeDocument/2006/relationships" id="259" r:id="R4997d3f55adc4ea7"/>
+    <p:sldId xmlns:r="http://schemas.openxmlformats.org/officeDocument/2006/relationships" id="260" r:id="R866b5d720cfb4c02"/>
+    <p:sldId xmlns:r="http://schemas.openxmlformats.org/officeDocument/2006/relationships" id="261" r:id="R6638a9f23072473e"/>
+    <p:sldId xmlns:r="http://schemas.openxmlformats.org/officeDocument/2006/relationships" id="262" r:id="R458cdae1b0f7462f"/>
+    <p:sldId xmlns:r="http://schemas.openxmlformats.org/officeDocument/2006/relationships" id="263" r:id="Rad0fd427837c41bd"/>
+    <p:sldId xmlns:r="http://schemas.openxmlformats.org/officeDocument/2006/relationships" id="264" r:id="R9a663e022c1848e9"/>
+    <p:sldId xmlns:r="http://schemas.openxmlformats.org/officeDocument/2006/relationships" id="265" r:id="R03d2749d45f5430a"/>
+    <p:sldId xmlns:r="http://schemas.openxmlformats.org/officeDocument/2006/relationships" id="266" r:id="R9e54a7629c594173"/>
   </p:sldIdLst>
   <p:sldSz cx="12192000" cy="6858000"/>
   <p:notesSz cx="6858000" cy="9144000"/>
@@ -592,7 +592,7 @@
           <a:lstStyle xmlns:a="http://schemas.openxmlformats.org/drawingml/2006/main"/>
           <a:p xmlns:a="http://schemas.openxmlformats.org/drawingml/2006/main">
             <a:r>
-              <a:t>Evidence: repository evidence index and attributed recovery summary. Single-server synthetic proof of concept, shared credential, same-account regional backups. Actual billing and comprehensive security validation not claimed. Teardown pending.</a:t>
+              <a:t>Evidence: repository evidence index and attributed recovery summary. Single-server synthetic proof of concept, shared credential, same-account regional backups. Actual billing and comprehensive security validation not claimed. Teardown completed, 25 resources destroyed. Independent API checks found zero remaining lab resources.</a:t>
             </a:r>
           </a:p>
         </p:txBody>
@@ -1220,7 +1220,7 @@
   </p:cSld>
   <p:clrMap bg1="lt1" tx1="dk1" bg2="lt2" tx2="dk2" accent1="accent1" accent2="accent2" accent3="accent3" accent4="accent4" accent5="accent5" accent6="accent6" hlink="hlink" folHlink="folHlink"/>
   <p:sldLayoutIdLst>
-    <p:sldLayoutId xmlns:r="http://schemas.openxmlformats.org/officeDocument/2006/relationships" id="2147483649" r:id="R08f1d363b9b745b5"/>
+    <p:sldLayoutId xmlns:r="http://schemas.openxmlformats.org/officeDocument/2006/relationships" id="2147483649" r:id="Rf60fd8346b814c1b"/>
   </p:sldLayoutIdLst>
   <p:txStyles>
     <p:titleStyle>
@@ -1771,7 +1771,7 @@
           <p:cNvPr id="9" name="">
             <a:extLst xmlns:a="http://schemas.openxmlformats.org/drawingml/2006/main">
               <a:ext uri="{FF2B5EF4-FFF2-40B4-BE49-F238E27FC236}">
-                <a16:creationId xmlns:a16="http://schemas.microsoft.com/office/drawing/2014/main" id="{60F5557F-93EB-4CA5-A354-0BF0EB478B35}"/>
+                <a16:creationId xmlns:a16="http://schemas.microsoft.com/office/drawing/2014/main" id="{08B63FD3-E07A-4F2F-B75E-12FEBC0F18F4}"/>
               </a:ext>
             </a:extLst>
           </p:cNvPr>
@@ -1828,7 +1828,7 @@
           <p:cNvPr id="2" name="">
             <a:extLst xmlns:a="http://schemas.openxmlformats.org/drawingml/2006/main">
               <a:ext uri="{FF2B5EF4-FFF2-40B4-BE49-F238E27FC236}">
-                <a16:creationId xmlns:a16="http://schemas.microsoft.com/office/drawing/2014/main" id="{64BC9F96-671B-4461-9551-1E6A8808D536}"/>
+                <a16:creationId xmlns:a16="http://schemas.microsoft.com/office/drawing/2014/main" id="{ED30C492-FB3C-4364-9EF6-C1F07352EAFF}"/>
               </a:ext>
             </a:extLst>
           </p:cNvPr>
@@ -1885,7 +1885,7 @@
           <p:cNvPr id="3" name="">
             <a:extLst xmlns:a="http://schemas.openxmlformats.org/drawingml/2006/main">
               <a:ext uri="{FF2B5EF4-FFF2-40B4-BE49-F238E27FC236}">
-                <a16:creationId xmlns:a16="http://schemas.microsoft.com/office/drawing/2014/main" id="{F62A4607-6871-4F68-914F-F9C3BEEAD4AE}"/>
+                <a16:creationId xmlns:a16="http://schemas.microsoft.com/office/drawing/2014/main" id="{2CBCC43E-BD8A-414E-AD57-991254A5FB5D}"/>
               </a:ext>
             </a:extLst>
           </p:cNvPr>
@@ -1942,7 +1942,7 @@
           <p:cNvPr id="4" name="">
             <a:extLst xmlns:a="http://schemas.openxmlformats.org/drawingml/2006/main">
               <a:ext uri="{FF2B5EF4-FFF2-40B4-BE49-F238E27FC236}">
-                <a16:creationId xmlns:a16="http://schemas.microsoft.com/office/drawing/2014/main" id="{BE2B2B64-69EE-480C-868F-A5AE6C3D8FC4}"/>
+                <a16:creationId xmlns:a16="http://schemas.microsoft.com/office/drawing/2014/main" id="{76CC8B0F-2B92-4ABC-A126-F44C9451FA0A}"/>
               </a:ext>
             </a:extLst>
           </p:cNvPr>
@@ -1999,7 +1999,7 @@
           <p:cNvPr id="5" name="">
             <a:extLst xmlns:a="http://schemas.openxmlformats.org/drawingml/2006/main">
               <a:ext uri="{FF2B5EF4-FFF2-40B4-BE49-F238E27FC236}">
-                <a16:creationId xmlns:a16="http://schemas.microsoft.com/office/drawing/2014/main" id="{4F4D88A6-C698-4938-BDAA-F7763B72C3EF}"/>
+                <a16:creationId xmlns:a16="http://schemas.microsoft.com/office/drawing/2014/main" id="{048D4259-3FE1-4542-8A5F-A9295A8EBBAF}"/>
               </a:ext>
             </a:extLst>
           </p:cNvPr>
@@ -2056,7 +2056,7 @@
           <p:cNvPr id="6" name="">
             <a:extLst xmlns:a="http://schemas.openxmlformats.org/drawingml/2006/main">
               <a:ext uri="{FF2B5EF4-FFF2-40B4-BE49-F238E27FC236}">
-                <a16:creationId xmlns:a16="http://schemas.microsoft.com/office/drawing/2014/main" id="{5FABA991-0201-4601-98EC-1AC85A284A78}"/>
+                <a16:creationId xmlns:a16="http://schemas.microsoft.com/office/drawing/2014/main" id="{85A51FFF-C823-4C09-A490-FC1563EEB572}"/>
               </a:ext>
             </a:extLst>
           </p:cNvPr>
@@ -2113,7 +2113,7 @@
           <p:cNvPr id="7" name="">
             <a:extLst xmlns:a="http://schemas.openxmlformats.org/drawingml/2006/main">
               <a:ext uri="{FF2B5EF4-FFF2-40B4-BE49-F238E27FC236}">
-                <a16:creationId xmlns:a16="http://schemas.microsoft.com/office/drawing/2014/main" id="{46ED2D44-3D04-4289-9002-9126FA919B1B}"/>
+                <a16:creationId xmlns:a16="http://schemas.microsoft.com/office/drawing/2014/main" id="{8765A2D7-E139-4A1A-8342-621E50F92E1F}"/>
               </a:ext>
             </a:extLst>
           </p:cNvPr>
@@ -2170,7 +2170,7 @@
           <p:cNvPr id="8" name="">
             <a:extLst xmlns:a="http://schemas.openxmlformats.org/drawingml/2006/main">
               <a:ext uri="{FF2B5EF4-FFF2-40B4-BE49-F238E27FC236}">
-                <a16:creationId xmlns:a16="http://schemas.microsoft.com/office/drawing/2014/main" id="{D11299E3-1DDD-4D8E-AE52-715E17801645}"/>
+                <a16:creationId xmlns:a16="http://schemas.microsoft.com/office/drawing/2014/main" id="{00E1F13A-657A-4920-94D2-15796847EA41}"/>
               </a:ext>
             </a:extLst>
           </p:cNvPr>
@@ -2225,7 +2225,7 @@
     </p:spTree>
     <p:extLst>
       <p:ext uri="{BB962C8B-B14F-4D97-AF65-F5344CB8AC3E}">
-        <p14:creationId xmlns:p14="http://schemas.microsoft.com/office/powerpoint/2010/main" val="1128963466"/>
+        <p14:creationId xmlns:p14="http://schemas.microsoft.com/office/powerpoint/2010/main" val="913566376"/>
       </p:ext>
     </p:extLst>
   </p:cSld>
@@ -2256,7 +2256,7 @@
           <p:cNvPr id="11" name="">
             <a:extLst xmlns:a="http://schemas.openxmlformats.org/drawingml/2006/main">
               <a:ext uri="{FF2B5EF4-FFF2-40B4-BE49-F238E27FC236}">
-                <a16:creationId xmlns:a16="http://schemas.microsoft.com/office/drawing/2014/main" id="{CA8F1F0B-90E8-4F8F-8730-3C45EAA95EB5}"/>
+                <a16:creationId xmlns:a16="http://schemas.microsoft.com/office/drawing/2014/main" id="{A699ACC2-BF05-404A-AD85-FA0E70D05DB3}"/>
               </a:ext>
             </a:extLst>
           </p:cNvPr>
@@ -2313,7 +2313,7 @@
           <p:cNvPr id="2" name="">
             <a:extLst xmlns:a="http://schemas.openxmlformats.org/drawingml/2006/main">
               <a:ext uri="{FF2B5EF4-FFF2-40B4-BE49-F238E27FC236}">
-                <a16:creationId xmlns:a16="http://schemas.microsoft.com/office/drawing/2014/main" id="{DF4056D5-6782-46DA-A97A-EB8D255CD8A4}"/>
+                <a16:creationId xmlns:a16="http://schemas.microsoft.com/office/drawing/2014/main" id="{A5B78A14-37AA-459E-9F9B-67B316FB2D50}"/>
               </a:ext>
             </a:extLst>
           </p:cNvPr>
@@ -2370,7 +2370,7 @@
           <p:cNvPr id="3" name="">
             <a:extLst xmlns:a="http://schemas.openxmlformats.org/drawingml/2006/main">
               <a:ext uri="{FF2B5EF4-FFF2-40B4-BE49-F238E27FC236}">
-                <a16:creationId xmlns:a16="http://schemas.microsoft.com/office/drawing/2014/main" id="{275EF9A3-5697-43F9-8755-5802B66A7EEA}"/>
+                <a16:creationId xmlns:a16="http://schemas.microsoft.com/office/drawing/2014/main" id="{E0D9C3AA-81BA-449E-B591-A0E043D065C3}"/>
               </a:ext>
             </a:extLst>
           </p:cNvPr>
@@ -2427,7 +2427,7 @@
           <p:cNvPr id="4" name="">
             <a:extLst xmlns:a="http://schemas.openxmlformats.org/drawingml/2006/main">
               <a:ext uri="{FF2B5EF4-FFF2-40B4-BE49-F238E27FC236}">
-                <a16:creationId xmlns:a16="http://schemas.microsoft.com/office/drawing/2014/main" id="{B2C44C22-B539-451C-8AA3-1639A2799DDA}"/>
+                <a16:creationId xmlns:a16="http://schemas.microsoft.com/office/drawing/2014/main" id="{72356938-E3B6-48C5-8799-6532B13A1F6C}"/>
               </a:ext>
             </a:extLst>
           </p:cNvPr>
@@ -2484,7 +2484,7 @@
           <p:cNvPr id="5" name="">
             <a:extLst xmlns:a="http://schemas.openxmlformats.org/drawingml/2006/main">
               <a:ext uri="{FF2B5EF4-FFF2-40B4-BE49-F238E27FC236}">
-                <a16:creationId xmlns:a16="http://schemas.microsoft.com/office/drawing/2014/main" id="{8614F9F5-4CF6-436B-AED8-7CA8FB1452FF}"/>
+                <a16:creationId xmlns:a16="http://schemas.microsoft.com/office/drawing/2014/main" id="{5D3820DC-9C01-4103-B3BD-DC8EAF80E84B}"/>
               </a:ext>
             </a:extLst>
           </p:cNvPr>
@@ -2541,7 +2541,7 @@
           <p:cNvPr id="6" name="">
             <a:extLst xmlns:a="http://schemas.openxmlformats.org/drawingml/2006/main">
               <a:ext uri="{FF2B5EF4-FFF2-40B4-BE49-F238E27FC236}">
-                <a16:creationId xmlns:a16="http://schemas.microsoft.com/office/drawing/2014/main" id="{82A7DAE6-0464-4070-ABB0-A3F337A01083}"/>
+                <a16:creationId xmlns:a16="http://schemas.microsoft.com/office/drawing/2014/main" id="{A7DBBF97-9FD9-4DA6-A250-62CF7EEE0244}"/>
               </a:ext>
             </a:extLst>
           </p:cNvPr>
@@ -2598,7 +2598,7 @@
           <p:cNvPr id="7" name="">
             <a:extLst xmlns:a="http://schemas.openxmlformats.org/drawingml/2006/main">
               <a:ext uri="{FF2B5EF4-FFF2-40B4-BE49-F238E27FC236}">
-                <a16:creationId xmlns:a16="http://schemas.microsoft.com/office/drawing/2014/main" id="{5CBB9661-FAF8-46F6-AEA7-0BBDC618AECC}"/>
+                <a16:creationId xmlns:a16="http://schemas.microsoft.com/office/drawing/2014/main" id="{66D45E2F-81C5-435B-9747-34941F518B70}"/>
               </a:ext>
             </a:extLst>
           </p:cNvPr>
@@ -2655,7 +2655,7 @@
           <p:cNvPr id="8" name="">
             <a:extLst xmlns:a="http://schemas.openxmlformats.org/drawingml/2006/main">
               <a:ext uri="{FF2B5EF4-FFF2-40B4-BE49-F238E27FC236}">
-                <a16:creationId xmlns:a16="http://schemas.microsoft.com/office/drawing/2014/main" id="{273A75A3-A116-4589-A704-A01AFF0BD80B}"/>
+                <a16:creationId xmlns:a16="http://schemas.microsoft.com/office/drawing/2014/main" id="{31E4FFB3-F91C-427A-9A05-40C4B783BB44}"/>
               </a:ext>
             </a:extLst>
           </p:cNvPr>
@@ -2712,7 +2712,7 @@
           <p:cNvPr id="9" name="">
             <a:extLst xmlns:a="http://schemas.openxmlformats.org/drawingml/2006/main">
               <a:ext uri="{FF2B5EF4-FFF2-40B4-BE49-F238E27FC236}">
-                <a16:creationId xmlns:a16="http://schemas.microsoft.com/office/drawing/2014/main" id="{0472A7F7-891D-47FE-8CA0-FF045F20CC39}"/>
+                <a16:creationId xmlns:a16="http://schemas.microsoft.com/office/drawing/2014/main" id="{F9D1BB07-1A94-42A6-B481-491C86A0D5D8}"/>
               </a:ext>
             </a:extLst>
           </p:cNvPr>
@@ -2769,7 +2769,7 @@
           <p:cNvPr id="10" name="">
             <a:extLst xmlns:a="http://schemas.openxmlformats.org/drawingml/2006/main">
               <a:ext uri="{FF2B5EF4-FFF2-40B4-BE49-F238E27FC236}">
-                <a16:creationId xmlns:a16="http://schemas.microsoft.com/office/drawing/2014/main" id="{7EF888AE-E2E5-4226-9089-850DE36E3D84}"/>
+                <a16:creationId xmlns:a16="http://schemas.microsoft.com/office/drawing/2014/main" id="{F83A75A1-82EF-4C81-9BE2-C5C966D9B788}"/>
               </a:ext>
             </a:extLst>
           </p:cNvPr>
@@ -2824,7 +2824,7 @@
     </p:spTree>
     <p:extLst>
       <p:ext uri="{BB962C8B-B14F-4D97-AF65-F5344CB8AC3E}">
-        <p14:creationId xmlns:p14="http://schemas.microsoft.com/office/powerpoint/2010/main" val="1587350881"/>
+        <p14:creationId xmlns:p14="http://schemas.microsoft.com/office/powerpoint/2010/main" val="1391106735"/>
       </p:ext>
     </p:extLst>
   </p:cSld>
@@ -2855,7 +2855,7 @@
           <p:cNvPr id="9" name="">
             <a:extLst xmlns:a="http://schemas.openxmlformats.org/drawingml/2006/main">
               <a:ext uri="{FF2B5EF4-FFF2-40B4-BE49-F238E27FC236}">
-                <a16:creationId xmlns:a16="http://schemas.microsoft.com/office/drawing/2014/main" id="{792C6EC7-8BA0-4E5B-BB57-87CE7B9A799D}"/>
+                <a16:creationId xmlns:a16="http://schemas.microsoft.com/office/drawing/2014/main" id="{C04A340D-9C32-4CFF-8268-D144F4C8457A}"/>
               </a:ext>
             </a:extLst>
           </p:cNvPr>
@@ -2912,7 +2912,7 @@
           <p:cNvPr id="2" name="">
             <a:extLst xmlns:a="http://schemas.openxmlformats.org/drawingml/2006/main">
               <a:ext uri="{FF2B5EF4-FFF2-40B4-BE49-F238E27FC236}">
-                <a16:creationId xmlns:a16="http://schemas.microsoft.com/office/drawing/2014/main" id="{9B30CE02-862B-4A43-A05F-4714B402C016}"/>
+                <a16:creationId xmlns:a16="http://schemas.microsoft.com/office/drawing/2014/main" id="{28F36660-1694-4163-90B2-6594991ACD2D}"/>
               </a:ext>
             </a:extLst>
           </p:cNvPr>
@@ -2969,7 +2969,7 @@
           <p:cNvPr id="3" name="">
             <a:extLst xmlns:a="http://schemas.openxmlformats.org/drawingml/2006/main">
               <a:ext uri="{FF2B5EF4-FFF2-40B4-BE49-F238E27FC236}">
-                <a16:creationId xmlns:a16="http://schemas.microsoft.com/office/drawing/2014/main" id="{B5456828-CB83-43BC-A45B-2AD718BB9260}"/>
+                <a16:creationId xmlns:a16="http://schemas.microsoft.com/office/drawing/2014/main" id="{7B1F514D-D591-40D8-B0F0-8B55AFE1D587}"/>
               </a:ext>
             </a:extLst>
           </p:cNvPr>
@@ -3026,7 +3026,7 @@
           <p:cNvPr id="4" name="">
             <a:extLst xmlns:a="http://schemas.openxmlformats.org/drawingml/2006/main">
               <a:ext uri="{FF2B5EF4-FFF2-40B4-BE49-F238E27FC236}">
-                <a16:creationId xmlns:a16="http://schemas.microsoft.com/office/drawing/2014/main" id="{DDB1F63B-4087-4BCB-AAA8-89ABAAE844BF}"/>
+                <a16:creationId xmlns:a16="http://schemas.microsoft.com/office/drawing/2014/main" id="{2F20062E-3B1A-47D4-B15B-96282835A53E}"/>
               </a:ext>
             </a:extLst>
           </p:cNvPr>
@@ -3083,7 +3083,7 @@
           <p:cNvPr id="5" name="">
             <a:extLst xmlns:a="http://schemas.openxmlformats.org/drawingml/2006/main">
               <a:ext uri="{FF2B5EF4-FFF2-40B4-BE49-F238E27FC236}">
-                <a16:creationId xmlns:a16="http://schemas.microsoft.com/office/drawing/2014/main" id="{831CE751-5982-46DF-8881-0263F4252760}"/>
+                <a16:creationId xmlns:a16="http://schemas.microsoft.com/office/drawing/2014/main" id="{9E27B2DC-0CF8-4B70-ADC9-58E66A975351}"/>
               </a:ext>
             </a:extLst>
           </p:cNvPr>
@@ -3140,7 +3140,7 @@
           <p:cNvPr id="6" name="">
             <a:extLst xmlns:a="http://schemas.openxmlformats.org/drawingml/2006/main">
               <a:ext uri="{FF2B5EF4-FFF2-40B4-BE49-F238E27FC236}">
-                <a16:creationId xmlns:a16="http://schemas.microsoft.com/office/drawing/2014/main" id="{71A929CF-C13A-48E4-8697-52EE34CB4B49}"/>
+                <a16:creationId xmlns:a16="http://schemas.microsoft.com/office/drawing/2014/main" id="{3469753D-05FE-427D-9B7E-3B5451B874A6}"/>
               </a:ext>
             </a:extLst>
           </p:cNvPr>
@@ -3197,7 +3197,7 @@
           <p:cNvPr id="7" name="">
             <a:extLst xmlns:a="http://schemas.openxmlformats.org/drawingml/2006/main">
               <a:ext uri="{FF2B5EF4-FFF2-40B4-BE49-F238E27FC236}">
-                <a16:creationId xmlns:a16="http://schemas.microsoft.com/office/drawing/2014/main" id="{28F8E421-994B-4465-A25F-A12770C8F196}"/>
+                <a16:creationId xmlns:a16="http://schemas.microsoft.com/office/drawing/2014/main" id="{A940486A-04C3-4AEC-B0B4-81EF21B42FF4}"/>
               </a:ext>
             </a:extLst>
           </p:cNvPr>
@@ -3254,7 +3254,7 @@
           <p:cNvPr id="8" name="">
             <a:extLst xmlns:a="http://schemas.openxmlformats.org/drawingml/2006/main">
               <a:ext uri="{FF2B5EF4-FFF2-40B4-BE49-F238E27FC236}">
-                <a16:creationId xmlns:a16="http://schemas.microsoft.com/office/drawing/2014/main" id="{ECF39918-7CB5-4AFF-BA6D-56D9B1B0627E}"/>
+                <a16:creationId xmlns:a16="http://schemas.microsoft.com/office/drawing/2014/main" id="{14E8C893-E803-4A6E-9769-2354106DCDEF}"/>
               </a:ext>
             </a:extLst>
           </p:cNvPr>
@@ -3301,7 +3301,7 @@
                 <a:ea typeface="Arial"/>
                 <a:cs typeface="Arial"/>
               </a:rPr>
-              <a:t>AWS teardown pending live Terraform access</a:t>
+              <a:t>25 resources destroyed. No active lab resources remain.</a:t>
             </a:r>
           </a:p>
         </p:txBody>
@@ -3309,7 +3309,7 @@
     </p:spTree>
     <p:extLst>
       <p:ext uri="{BB962C8B-B14F-4D97-AF65-F5344CB8AC3E}">
-        <p14:creationId xmlns:p14="http://schemas.microsoft.com/office/powerpoint/2010/main" val="532013604"/>
+        <p14:creationId xmlns:p14="http://schemas.microsoft.com/office/powerpoint/2010/main" val="337822780"/>
       </p:ext>
     </p:extLst>
   </p:cSld>
@@ -3340,7 +3340,7 @@
           <p:cNvPr id="11" name="">
             <a:extLst xmlns:a="http://schemas.openxmlformats.org/drawingml/2006/main">
               <a:ext uri="{FF2B5EF4-FFF2-40B4-BE49-F238E27FC236}">
-                <a16:creationId xmlns:a16="http://schemas.microsoft.com/office/drawing/2014/main" id="{63A2B387-27EF-4170-9DAF-2BA393955E05}"/>
+                <a16:creationId xmlns:a16="http://schemas.microsoft.com/office/drawing/2014/main" id="{A6795117-9830-431B-8678-BE27837E9F2B}"/>
               </a:ext>
             </a:extLst>
           </p:cNvPr>
@@ -3397,7 +3397,7 @@
           <p:cNvPr id="2" name="">
             <a:extLst xmlns:a="http://schemas.openxmlformats.org/drawingml/2006/main">
               <a:ext uri="{FF2B5EF4-FFF2-40B4-BE49-F238E27FC236}">
-                <a16:creationId xmlns:a16="http://schemas.microsoft.com/office/drawing/2014/main" id="{924CB882-3652-428F-96EA-7E1AB9BF6C10}"/>
+                <a16:creationId xmlns:a16="http://schemas.microsoft.com/office/drawing/2014/main" id="{8D57528A-C549-49FF-A0EC-9083F37B87B2}"/>
               </a:ext>
             </a:extLst>
           </p:cNvPr>
@@ -3454,7 +3454,7 @@
           <p:cNvPr id="3" name="">
             <a:extLst xmlns:a="http://schemas.openxmlformats.org/drawingml/2006/main">
               <a:ext uri="{FF2B5EF4-FFF2-40B4-BE49-F238E27FC236}">
-                <a16:creationId xmlns:a16="http://schemas.microsoft.com/office/drawing/2014/main" id="{4F52493B-AC94-4646-81AD-D2CA041EC61F}"/>
+                <a16:creationId xmlns:a16="http://schemas.microsoft.com/office/drawing/2014/main" id="{C1507D41-BAD2-49A4-9E12-E03AAC7C341C}"/>
               </a:ext>
             </a:extLst>
           </p:cNvPr>
@@ -3511,7 +3511,7 @@
           <p:cNvPr id="4" name="">
             <a:extLst xmlns:a="http://schemas.openxmlformats.org/drawingml/2006/main">
               <a:ext uri="{FF2B5EF4-FFF2-40B4-BE49-F238E27FC236}">
-                <a16:creationId xmlns:a16="http://schemas.microsoft.com/office/drawing/2014/main" id="{2BE3F3A2-6887-4DDA-8138-882D89D1F93A}"/>
+                <a16:creationId xmlns:a16="http://schemas.microsoft.com/office/drawing/2014/main" id="{CC7640CF-50EB-43A0-82B1-43E241A7A4DC}"/>
               </a:ext>
             </a:extLst>
           </p:cNvPr>
@@ -3568,7 +3568,7 @@
           <p:cNvPr id="5" name="">
             <a:extLst xmlns:a="http://schemas.openxmlformats.org/drawingml/2006/main">
               <a:ext uri="{FF2B5EF4-FFF2-40B4-BE49-F238E27FC236}">
-                <a16:creationId xmlns:a16="http://schemas.microsoft.com/office/drawing/2014/main" id="{C3CB3EB5-7B40-4E5F-880C-4FE079A5B415}"/>
+                <a16:creationId xmlns:a16="http://schemas.microsoft.com/office/drawing/2014/main" id="{BDBF2EB7-FDD8-4D93-A331-599C10B57459}"/>
               </a:ext>
             </a:extLst>
           </p:cNvPr>
@@ -3625,7 +3625,7 @@
           <p:cNvPr id="6" name="">
             <a:extLst xmlns:a="http://schemas.openxmlformats.org/drawingml/2006/main">
               <a:ext uri="{FF2B5EF4-FFF2-40B4-BE49-F238E27FC236}">
-                <a16:creationId xmlns:a16="http://schemas.microsoft.com/office/drawing/2014/main" id="{917CE6B5-DFE8-495F-AAF3-3C372FDCB299}"/>
+                <a16:creationId xmlns:a16="http://schemas.microsoft.com/office/drawing/2014/main" id="{5CE9FE00-DAB5-415F-9B65-BB45C7F8A08C}"/>
               </a:ext>
             </a:extLst>
           </p:cNvPr>
@@ -3682,7 +3682,7 @@
           <p:cNvPr id="7" name="">
             <a:extLst xmlns:a="http://schemas.openxmlformats.org/drawingml/2006/main">
               <a:ext uri="{FF2B5EF4-FFF2-40B4-BE49-F238E27FC236}">
-                <a16:creationId xmlns:a16="http://schemas.microsoft.com/office/drawing/2014/main" id="{9FBA66B7-FC85-4C3F-85EC-10F025199030}"/>
+                <a16:creationId xmlns:a16="http://schemas.microsoft.com/office/drawing/2014/main" id="{19B35FA6-E995-4517-A45A-C6C965267F35}"/>
               </a:ext>
             </a:extLst>
           </p:cNvPr>
@@ -3739,7 +3739,7 @@
           <p:cNvPr id="8" name="">
             <a:extLst xmlns:a="http://schemas.openxmlformats.org/drawingml/2006/main">
               <a:ext uri="{FF2B5EF4-FFF2-40B4-BE49-F238E27FC236}">
-                <a16:creationId xmlns:a16="http://schemas.microsoft.com/office/drawing/2014/main" id="{2D44C3D1-F99E-4DEF-BB55-62D6CD8746BD}"/>
+                <a16:creationId xmlns:a16="http://schemas.microsoft.com/office/drawing/2014/main" id="{E36B4A89-D48B-42BA-9361-07D1D287D7E2}"/>
               </a:ext>
             </a:extLst>
           </p:cNvPr>
@@ -3796,7 +3796,7 @@
           <p:cNvPr id="9" name="">
             <a:extLst xmlns:a="http://schemas.openxmlformats.org/drawingml/2006/main">
               <a:ext uri="{FF2B5EF4-FFF2-40B4-BE49-F238E27FC236}">
-                <a16:creationId xmlns:a16="http://schemas.microsoft.com/office/drawing/2014/main" id="{A62A594D-1AC1-4C87-AA1C-EA5587F53B5D}"/>
+                <a16:creationId xmlns:a16="http://schemas.microsoft.com/office/drawing/2014/main" id="{614D2620-D608-48C7-9F57-EDA3E96EAF37}"/>
               </a:ext>
             </a:extLst>
           </p:cNvPr>
@@ -3853,7 +3853,7 @@
           <p:cNvPr id="10" name="">
             <a:extLst xmlns:a="http://schemas.openxmlformats.org/drawingml/2006/main">
               <a:ext uri="{FF2B5EF4-FFF2-40B4-BE49-F238E27FC236}">
-                <a16:creationId xmlns:a16="http://schemas.microsoft.com/office/drawing/2014/main" id="{9FFB080C-8930-40B6-8D77-5C0F6D03F44B}"/>
+                <a16:creationId xmlns:a16="http://schemas.microsoft.com/office/drawing/2014/main" id="{B752339D-7068-4F1B-9F1F-6C0AA5B25724}"/>
               </a:ext>
             </a:extLst>
           </p:cNvPr>
@@ -3908,7 +3908,7 @@
     </p:spTree>
     <p:extLst>
       <p:ext uri="{BB962C8B-B14F-4D97-AF65-F5344CB8AC3E}">
-        <p14:creationId xmlns:p14="http://schemas.microsoft.com/office/powerpoint/2010/main" val="1656819020"/>
+        <p14:creationId xmlns:p14="http://schemas.microsoft.com/office/powerpoint/2010/main" val="1513357070"/>
       </p:ext>
     </p:extLst>
   </p:cSld>
@@ -3939,7 +3939,7 @@
           <p:cNvPr id="15" name="">
             <a:extLst xmlns:a="http://schemas.openxmlformats.org/drawingml/2006/main">
               <a:ext uri="{FF2B5EF4-FFF2-40B4-BE49-F238E27FC236}">
-                <a16:creationId xmlns:a16="http://schemas.microsoft.com/office/drawing/2014/main" id="{38D58525-B652-42F8-8244-073C32B430F1}"/>
+                <a16:creationId xmlns:a16="http://schemas.microsoft.com/office/drawing/2014/main" id="{48F2087D-70CD-4232-98FF-5EDD09970764}"/>
               </a:ext>
             </a:extLst>
           </p:cNvPr>
@@ -3996,7 +3996,7 @@
           <p:cNvPr id="2" name="">
             <a:extLst xmlns:a="http://schemas.openxmlformats.org/drawingml/2006/main">
               <a:ext uri="{FF2B5EF4-FFF2-40B4-BE49-F238E27FC236}">
-                <a16:creationId xmlns:a16="http://schemas.microsoft.com/office/drawing/2014/main" id="{1E8D17A8-0EFC-4C1D-BCD6-682125B04F8B}"/>
+                <a16:creationId xmlns:a16="http://schemas.microsoft.com/office/drawing/2014/main" id="{F52F8070-8361-4CD4-A6BD-D58D6210F247}"/>
               </a:ext>
             </a:extLst>
           </p:cNvPr>
@@ -4053,7 +4053,7 @@
           <p:cNvPr id="3" name="">
             <a:extLst xmlns:a="http://schemas.openxmlformats.org/drawingml/2006/main">
               <a:ext uri="{FF2B5EF4-FFF2-40B4-BE49-F238E27FC236}">
-                <a16:creationId xmlns:a16="http://schemas.microsoft.com/office/drawing/2014/main" id="{AA0EED63-3B46-4094-A685-613D8F84148F}"/>
+                <a16:creationId xmlns:a16="http://schemas.microsoft.com/office/drawing/2014/main" id="{10BE2E93-3AE8-4C4A-AFBD-355BE505B399}"/>
               </a:ext>
             </a:extLst>
           </p:cNvPr>
@@ -4110,7 +4110,7 @@
           <p:cNvPr id="4" name="">
             <a:extLst xmlns:a="http://schemas.openxmlformats.org/drawingml/2006/main">
               <a:ext uri="{FF2B5EF4-FFF2-40B4-BE49-F238E27FC236}">
-                <a16:creationId xmlns:a16="http://schemas.microsoft.com/office/drawing/2014/main" id="{B20B31CC-2C26-4F00-9FAD-B54B20736937}"/>
+                <a16:creationId xmlns:a16="http://schemas.microsoft.com/office/drawing/2014/main" id="{0045AADA-3E4C-4CBF-BA9A-CFF5AC3A803E}"/>
               </a:ext>
             </a:extLst>
           </p:cNvPr>
@@ -4167,7 +4167,7 @@
           <p:cNvPr id="5" name="">
             <a:extLst xmlns:a="http://schemas.openxmlformats.org/drawingml/2006/main">
               <a:ext uri="{FF2B5EF4-FFF2-40B4-BE49-F238E27FC236}">
-                <a16:creationId xmlns:a16="http://schemas.microsoft.com/office/drawing/2014/main" id="{35D4613E-0BCB-486A-9054-1D7B5CADE055}"/>
+                <a16:creationId xmlns:a16="http://schemas.microsoft.com/office/drawing/2014/main" id="{3892064C-F257-40D3-A296-61619665ADE7}"/>
               </a:ext>
             </a:extLst>
           </p:cNvPr>
@@ -4224,7 +4224,7 @@
           <p:cNvPr id="6" name="">
             <a:extLst xmlns:a="http://schemas.openxmlformats.org/drawingml/2006/main">
               <a:ext uri="{FF2B5EF4-FFF2-40B4-BE49-F238E27FC236}">
-                <a16:creationId xmlns:a16="http://schemas.microsoft.com/office/drawing/2014/main" id="{8A69A252-4C44-4C77-8FA5-75C9E7B14CA7}"/>
+                <a16:creationId xmlns:a16="http://schemas.microsoft.com/office/drawing/2014/main" id="{F18F3800-30E9-4BB6-B340-71207173FC54}"/>
               </a:ext>
             </a:extLst>
           </p:cNvPr>
@@ -4281,7 +4281,7 @@
           <p:cNvPr id="7" name="">
             <a:extLst xmlns:a="http://schemas.openxmlformats.org/drawingml/2006/main">
               <a:ext uri="{FF2B5EF4-FFF2-40B4-BE49-F238E27FC236}">
-                <a16:creationId xmlns:a16="http://schemas.microsoft.com/office/drawing/2014/main" id="{1C183BE6-A6F7-4C7A-B143-CEB1DF8613F5}"/>
+                <a16:creationId xmlns:a16="http://schemas.microsoft.com/office/drawing/2014/main" id="{F82E27FC-F63D-46F5-80F2-D455DFD898B5}"/>
               </a:ext>
             </a:extLst>
           </p:cNvPr>
@@ -4338,7 +4338,7 @@
           <p:cNvPr id="8" name="">
             <a:extLst xmlns:a="http://schemas.openxmlformats.org/drawingml/2006/main">
               <a:ext uri="{FF2B5EF4-FFF2-40B4-BE49-F238E27FC236}">
-                <a16:creationId xmlns:a16="http://schemas.microsoft.com/office/drawing/2014/main" id="{8F60EF60-B8E2-466F-80BF-BCE4138B61F0}"/>
+                <a16:creationId xmlns:a16="http://schemas.microsoft.com/office/drawing/2014/main" id="{D2144C8E-ACC0-4BAF-A7EE-26F29A37590B}"/>
               </a:ext>
             </a:extLst>
           </p:cNvPr>
@@ -4418,7 +4418,7 @@
           <p:cNvPr id="9" name="">
             <a:extLst xmlns:a="http://schemas.openxmlformats.org/drawingml/2006/main">
               <a:ext uri="{FF2B5EF4-FFF2-40B4-BE49-F238E27FC236}">
-                <a16:creationId xmlns:a16="http://schemas.microsoft.com/office/drawing/2014/main" id="{01FF2184-703E-4C0F-80EC-ED4D744530C0}"/>
+                <a16:creationId xmlns:a16="http://schemas.microsoft.com/office/drawing/2014/main" id="{2D6638C3-5A95-4A42-B8D1-6D1D8150166D}"/>
               </a:ext>
             </a:extLst>
           </p:cNvPr>
@@ -4475,7 +4475,7 @@
           <p:cNvPr id="10" name="">
             <a:extLst xmlns:a="http://schemas.openxmlformats.org/drawingml/2006/main">
               <a:ext uri="{FF2B5EF4-FFF2-40B4-BE49-F238E27FC236}">
-                <a16:creationId xmlns:a16="http://schemas.microsoft.com/office/drawing/2014/main" id="{54FF4FA5-74CD-4BDA-8161-05B6DAA7209D}"/>
+                <a16:creationId xmlns:a16="http://schemas.microsoft.com/office/drawing/2014/main" id="{30D83119-4A08-4F0A-B13D-11784CD8F3C4}"/>
               </a:ext>
             </a:extLst>
           </p:cNvPr>
@@ -4555,7 +4555,7 @@
           <p:cNvPr id="11" name="">
             <a:extLst xmlns:a="http://schemas.openxmlformats.org/drawingml/2006/main">
               <a:ext uri="{FF2B5EF4-FFF2-40B4-BE49-F238E27FC236}">
-                <a16:creationId xmlns:a16="http://schemas.microsoft.com/office/drawing/2014/main" id="{0531B468-EB73-4ABC-88CB-5C009AABEDE0}"/>
+                <a16:creationId xmlns:a16="http://schemas.microsoft.com/office/drawing/2014/main" id="{2157EF83-3C5F-4CD8-A6E3-650D7AA269D1}"/>
               </a:ext>
             </a:extLst>
           </p:cNvPr>
@@ -4612,7 +4612,7 @@
           <p:cNvPr id="12" name="">
             <a:extLst xmlns:a="http://schemas.openxmlformats.org/drawingml/2006/main">
               <a:ext uri="{FF2B5EF4-FFF2-40B4-BE49-F238E27FC236}">
-                <a16:creationId xmlns:a16="http://schemas.microsoft.com/office/drawing/2014/main" id="{B925AD62-A916-414C-9AE9-49FB053144C4}"/>
+                <a16:creationId xmlns:a16="http://schemas.microsoft.com/office/drawing/2014/main" id="{2CD073FB-E97B-480C-96E0-565E61107273}"/>
               </a:ext>
             </a:extLst>
           </p:cNvPr>
@@ -4669,7 +4669,7 @@
           <p:cNvPr id="13" name="">
             <a:extLst xmlns:a="http://schemas.openxmlformats.org/drawingml/2006/main">
               <a:ext uri="{FF2B5EF4-FFF2-40B4-BE49-F238E27FC236}">
-                <a16:creationId xmlns:a16="http://schemas.microsoft.com/office/drawing/2014/main" id="{544B8430-BB98-410F-8393-E7A5587DE6EE}"/>
+                <a16:creationId xmlns:a16="http://schemas.microsoft.com/office/drawing/2014/main" id="{B41B504C-CE1C-4B4D-8A1E-47255DEC9013}"/>
               </a:ext>
             </a:extLst>
           </p:cNvPr>
@@ -4726,7 +4726,7 @@
           <p:cNvPr id="14" name="">
             <a:extLst xmlns:a="http://schemas.openxmlformats.org/drawingml/2006/main">
               <a:ext uri="{FF2B5EF4-FFF2-40B4-BE49-F238E27FC236}">
-                <a16:creationId xmlns:a16="http://schemas.microsoft.com/office/drawing/2014/main" id="{4AD0E196-71EB-4B5F-BA41-2AC17BEF8FCD}"/>
+                <a16:creationId xmlns:a16="http://schemas.microsoft.com/office/drawing/2014/main" id="{D8F0C926-7BBC-4D45-98A7-A4707947915F}"/>
               </a:ext>
             </a:extLst>
           </p:cNvPr>
@@ -4781,7 +4781,7 @@
     </p:spTree>
     <p:extLst>
       <p:ext uri="{BB962C8B-B14F-4D97-AF65-F5344CB8AC3E}">
-        <p14:creationId xmlns:p14="http://schemas.microsoft.com/office/powerpoint/2010/main" val="251963997"/>
+        <p14:creationId xmlns:p14="http://schemas.microsoft.com/office/powerpoint/2010/main" val="902785202"/>
       </p:ext>
     </p:extLst>
   </p:cSld>
@@ -4812,7 +4812,7 @@
           <p:cNvPr id="11" name="">
             <a:extLst xmlns:a="http://schemas.openxmlformats.org/drawingml/2006/main">
               <a:ext uri="{FF2B5EF4-FFF2-40B4-BE49-F238E27FC236}">
-                <a16:creationId xmlns:a16="http://schemas.microsoft.com/office/drawing/2014/main" id="{76198C3E-F968-47D4-A4E6-4C0611486DB1}"/>
+                <a16:creationId xmlns:a16="http://schemas.microsoft.com/office/drawing/2014/main" id="{F8B0675C-81AB-4092-816B-FD2F93EACFC7}"/>
               </a:ext>
             </a:extLst>
           </p:cNvPr>
@@ -4869,7 +4869,7 @@
           <p:cNvPr id="2" name="">
             <a:extLst xmlns:a="http://schemas.openxmlformats.org/drawingml/2006/main">
               <a:ext uri="{FF2B5EF4-FFF2-40B4-BE49-F238E27FC236}">
-                <a16:creationId xmlns:a16="http://schemas.microsoft.com/office/drawing/2014/main" id="{25667E03-15AD-44F3-99B7-F1E922DE7B48}"/>
+                <a16:creationId xmlns:a16="http://schemas.microsoft.com/office/drawing/2014/main" id="{3ACB3008-1F0C-45BE-BAD0-F1E02B8B86CD}"/>
               </a:ext>
             </a:extLst>
           </p:cNvPr>
@@ -4926,7 +4926,7 @@
           <p:cNvPr id="3" name="">
             <a:extLst xmlns:a="http://schemas.openxmlformats.org/drawingml/2006/main">
               <a:ext uri="{FF2B5EF4-FFF2-40B4-BE49-F238E27FC236}">
-                <a16:creationId xmlns:a16="http://schemas.microsoft.com/office/drawing/2014/main" id="{38382D22-7F1D-4203-8F2E-84202F2D5192}"/>
+                <a16:creationId xmlns:a16="http://schemas.microsoft.com/office/drawing/2014/main" id="{9E48B8B7-56E8-44EE-A819-C5D31A8E10AE}"/>
               </a:ext>
             </a:extLst>
           </p:cNvPr>
@@ -4983,7 +4983,7 @@
           <p:cNvPr id="4" name="">
             <a:extLst xmlns:a="http://schemas.openxmlformats.org/drawingml/2006/main">
               <a:ext uri="{FF2B5EF4-FFF2-40B4-BE49-F238E27FC236}">
-                <a16:creationId xmlns:a16="http://schemas.microsoft.com/office/drawing/2014/main" id="{56E98C6C-0CDF-4B62-8022-2BEE0F1247AA}"/>
+                <a16:creationId xmlns:a16="http://schemas.microsoft.com/office/drawing/2014/main" id="{48002A0A-13D9-47CC-BCF5-5E08104D48B9}"/>
               </a:ext>
             </a:extLst>
           </p:cNvPr>
@@ -5040,7 +5040,7 @@
           <p:cNvPr id="5" name="">
             <a:extLst xmlns:a="http://schemas.openxmlformats.org/drawingml/2006/main">
               <a:ext uri="{FF2B5EF4-FFF2-40B4-BE49-F238E27FC236}">
-                <a16:creationId xmlns:a16="http://schemas.microsoft.com/office/drawing/2014/main" id="{4AEB105F-6026-4FE1-B39E-12B14B524E78}"/>
+                <a16:creationId xmlns:a16="http://schemas.microsoft.com/office/drawing/2014/main" id="{A295AD5C-4E1A-4ACD-B192-D0FB999E12BD}"/>
               </a:ext>
             </a:extLst>
           </p:cNvPr>
@@ -5097,7 +5097,7 @@
           <p:cNvPr id="6" name="">
             <a:extLst xmlns:a="http://schemas.openxmlformats.org/drawingml/2006/main">
               <a:ext uri="{FF2B5EF4-FFF2-40B4-BE49-F238E27FC236}">
-                <a16:creationId xmlns:a16="http://schemas.microsoft.com/office/drawing/2014/main" id="{26BD6E4B-EE96-4CB1-A7A2-5593F10FE95B}"/>
+                <a16:creationId xmlns:a16="http://schemas.microsoft.com/office/drawing/2014/main" id="{FEE34CDA-47E8-4C6A-AE57-385646550A55}"/>
               </a:ext>
             </a:extLst>
           </p:cNvPr>
@@ -5154,7 +5154,7 @@
           <p:cNvPr id="7" name="">
             <a:extLst xmlns:a="http://schemas.openxmlformats.org/drawingml/2006/main">
               <a:ext uri="{FF2B5EF4-FFF2-40B4-BE49-F238E27FC236}">
-                <a16:creationId xmlns:a16="http://schemas.microsoft.com/office/drawing/2014/main" id="{E5E41B54-BEA1-409D-BB59-25001A59AA8D}"/>
+                <a16:creationId xmlns:a16="http://schemas.microsoft.com/office/drawing/2014/main" id="{6638E485-953F-430B-9493-04DD9F66E431}"/>
               </a:ext>
             </a:extLst>
           </p:cNvPr>
@@ -5211,7 +5211,7 @@
           <p:cNvPr id="8" name="">
             <a:extLst xmlns:a="http://schemas.openxmlformats.org/drawingml/2006/main">
               <a:ext uri="{FF2B5EF4-FFF2-40B4-BE49-F238E27FC236}">
-                <a16:creationId xmlns:a16="http://schemas.microsoft.com/office/drawing/2014/main" id="{8FC62850-7EF8-4361-A10B-7E130F74E019}"/>
+                <a16:creationId xmlns:a16="http://schemas.microsoft.com/office/drawing/2014/main" id="{2743E02C-3C23-4A99-BA7D-4A2530D2E865}"/>
               </a:ext>
             </a:extLst>
           </p:cNvPr>
@@ -5268,7 +5268,7 @@
           <p:cNvPr id="9" name="">
             <a:extLst xmlns:a="http://schemas.openxmlformats.org/drawingml/2006/main">
               <a:ext uri="{FF2B5EF4-FFF2-40B4-BE49-F238E27FC236}">
-                <a16:creationId xmlns:a16="http://schemas.microsoft.com/office/drawing/2014/main" id="{380B6EF8-A751-4B61-B762-E28C3D6892BF}"/>
+                <a16:creationId xmlns:a16="http://schemas.microsoft.com/office/drawing/2014/main" id="{9FA275A9-2412-4506-8163-07053A204989}"/>
               </a:ext>
             </a:extLst>
           </p:cNvPr>
@@ -5325,7 +5325,7 @@
           <p:cNvPr id="10" name="">
             <a:extLst xmlns:a="http://schemas.openxmlformats.org/drawingml/2006/main">
               <a:ext uri="{FF2B5EF4-FFF2-40B4-BE49-F238E27FC236}">
-                <a16:creationId xmlns:a16="http://schemas.microsoft.com/office/drawing/2014/main" id="{F51107BE-F25B-4718-A947-005C40BDD563}"/>
+                <a16:creationId xmlns:a16="http://schemas.microsoft.com/office/drawing/2014/main" id="{3054375C-E5BD-41D6-9501-6B229B98E03F}"/>
               </a:ext>
             </a:extLst>
           </p:cNvPr>
@@ -5372,7 +5372,7 @@
                 <a:ea typeface="Arial"/>
                 <a:cs typeface="Arial"/>
               </a:rPr>
-              <a:t>The retained final app screenshot corroborates the workload. Earlier baseline screenshots and migration transcript were unavailable in this closeout.</a:t>
+              <a:t>The final app screenshot corroborates the workload. The exported migration database has five jobs and integrity ok.</a:t>
             </a:r>
           </a:p>
         </p:txBody>
@@ -5380,7 +5380,7 @@
     </p:spTree>
     <p:extLst>
       <p:ext uri="{BB962C8B-B14F-4D97-AF65-F5344CB8AC3E}">
-        <p14:creationId xmlns:p14="http://schemas.microsoft.com/office/powerpoint/2010/main" val="1118787934"/>
+        <p14:creationId xmlns:p14="http://schemas.microsoft.com/office/powerpoint/2010/main" val="1989754417"/>
       </p:ext>
     </p:extLst>
   </p:cSld>
@@ -5411,7 +5411,7 @@
           <p:cNvPr id="11" name="">
             <a:extLst xmlns:a="http://schemas.openxmlformats.org/drawingml/2006/main">
               <a:ext uri="{FF2B5EF4-FFF2-40B4-BE49-F238E27FC236}">
-                <a16:creationId xmlns:a16="http://schemas.microsoft.com/office/drawing/2014/main" id="{353C879B-5547-4B0A-9EA7-4CC7C2CD12CA}"/>
+                <a16:creationId xmlns:a16="http://schemas.microsoft.com/office/drawing/2014/main" id="{D1F9C1FE-31D3-4F64-AA64-958694C8D5B0}"/>
               </a:ext>
             </a:extLst>
           </p:cNvPr>
@@ -5468,7 +5468,7 @@
           <p:cNvPr id="2" name="">
             <a:extLst xmlns:a="http://schemas.openxmlformats.org/drawingml/2006/main">
               <a:ext uri="{FF2B5EF4-FFF2-40B4-BE49-F238E27FC236}">
-                <a16:creationId xmlns:a16="http://schemas.microsoft.com/office/drawing/2014/main" id="{13080D5F-5576-47D4-9A8A-1587F375ED50}"/>
+                <a16:creationId xmlns:a16="http://schemas.microsoft.com/office/drawing/2014/main" id="{A774E824-BE3D-49F5-8CEB-814C12AA82B1}"/>
               </a:ext>
             </a:extLst>
           </p:cNvPr>
@@ -5525,7 +5525,7 @@
           <p:cNvPr id="3" name="">
             <a:extLst xmlns:a="http://schemas.openxmlformats.org/drawingml/2006/main">
               <a:ext uri="{FF2B5EF4-FFF2-40B4-BE49-F238E27FC236}">
-                <a16:creationId xmlns:a16="http://schemas.microsoft.com/office/drawing/2014/main" id="{9CAB63D3-84B4-42BD-B699-57C3E915BA41}"/>
+                <a16:creationId xmlns:a16="http://schemas.microsoft.com/office/drawing/2014/main" id="{9C3F5392-AF9C-4310-9AD2-D60A305EEEF4}"/>
               </a:ext>
             </a:extLst>
           </p:cNvPr>
@@ -5582,7 +5582,7 @@
           <p:cNvPr id="4" name="">
             <a:extLst xmlns:a="http://schemas.openxmlformats.org/drawingml/2006/main">
               <a:ext uri="{FF2B5EF4-FFF2-40B4-BE49-F238E27FC236}">
-                <a16:creationId xmlns:a16="http://schemas.microsoft.com/office/drawing/2014/main" id="{D0B23128-4904-463F-AF11-544AFE7C6669}"/>
+                <a16:creationId xmlns:a16="http://schemas.microsoft.com/office/drawing/2014/main" id="{D1BF29F5-3F69-426B-B70B-62F031EF3B6C}"/>
               </a:ext>
             </a:extLst>
           </p:cNvPr>
@@ -5639,7 +5639,7 @@
           <p:cNvPr id="5" name="">
             <a:extLst xmlns:a="http://schemas.openxmlformats.org/drawingml/2006/main">
               <a:ext uri="{FF2B5EF4-FFF2-40B4-BE49-F238E27FC236}">
-                <a16:creationId xmlns:a16="http://schemas.microsoft.com/office/drawing/2014/main" id="{D3F676C0-0D65-44F9-8F83-0144B2302677}"/>
+                <a16:creationId xmlns:a16="http://schemas.microsoft.com/office/drawing/2014/main" id="{8045D1BC-F433-4EAF-A588-F61732A98234}"/>
               </a:ext>
             </a:extLst>
           </p:cNvPr>
@@ -5696,7 +5696,7 @@
           <p:cNvPr id="6" name="">
             <a:extLst xmlns:a="http://schemas.openxmlformats.org/drawingml/2006/main">
               <a:ext uri="{FF2B5EF4-FFF2-40B4-BE49-F238E27FC236}">
-                <a16:creationId xmlns:a16="http://schemas.microsoft.com/office/drawing/2014/main" id="{4A534756-6C54-4500-81DC-BE484A2A478E}"/>
+                <a16:creationId xmlns:a16="http://schemas.microsoft.com/office/drawing/2014/main" id="{F10C9881-72E4-41BA-90FF-E1FC876D15C0}"/>
               </a:ext>
             </a:extLst>
           </p:cNvPr>
@@ -5753,7 +5753,7 @@
           <p:cNvPr id="7" name="">
             <a:extLst xmlns:a="http://schemas.openxmlformats.org/drawingml/2006/main">
               <a:ext uri="{FF2B5EF4-FFF2-40B4-BE49-F238E27FC236}">
-                <a16:creationId xmlns:a16="http://schemas.microsoft.com/office/drawing/2014/main" id="{A8A083C9-7B32-4456-9F0E-2C8B2F81873A}"/>
+                <a16:creationId xmlns:a16="http://schemas.microsoft.com/office/drawing/2014/main" id="{7375B926-1459-41DA-9F9C-0B75376D6B9E}"/>
               </a:ext>
             </a:extLst>
           </p:cNvPr>
@@ -5810,7 +5810,7 @@
           <p:cNvPr id="8" name="">
             <a:extLst xmlns:a="http://schemas.openxmlformats.org/drawingml/2006/main">
               <a:ext uri="{FF2B5EF4-FFF2-40B4-BE49-F238E27FC236}">
-                <a16:creationId xmlns:a16="http://schemas.microsoft.com/office/drawing/2014/main" id="{1AF08DCE-5003-4F75-8DC4-CAAEE69646D3}"/>
+                <a16:creationId xmlns:a16="http://schemas.microsoft.com/office/drawing/2014/main" id="{DE317592-7A55-481D-A7C6-86D89FCFA168}"/>
               </a:ext>
             </a:extLst>
           </p:cNvPr>
@@ -5867,7 +5867,7 @@
           <p:cNvPr id="9" name="">
             <a:extLst xmlns:a="http://schemas.openxmlformats.org/drawingml/2006/main">
               <a:ext uri="{FF2B5EF4-FFF2-40B4-BE49-F238E27FC236}">
-                <a16:creationId xmlns:a16="http://schemas.microsoft.com/office/drawing/2014/main" id="{24945EF8-A197-4A75-BFCC-F4C18CC93796}"/>
+                <a16:creationId xmlns:a16="http://schemas.microsoft.com/office/drawing/2014/main" id="{FF9A8205-8040-43A6-B47D-95A457B69BA3}"/>
               </a:ext>
             </a:extLst>
           </p:cNvPr>
@@ -5924,7 +5924,7 @@
           <p:cNvPr id="10" name="">
             <a:extLst xmlns:a="http://schemas.openxmlformats.org/drawingml/2006/main">
               <a:ext uri="{FF2B5EF4-FFF2-40B4-BE49-F238E27FC236}">
-                <a16:creationId xmlns:a16="http://schemas.microsoft.com/office/drawing/2014/main" id="{68C8FFB1-7453-4C97-90EA-AA8818D1780A}"/>
+                <a16:creationId xmlns:a16="http://schemas.microsoft.com/office/drawing/2014/main" id="{5E8470F0-C2D2-46C6-B022-D69C0AAB6D9A}"/>
               </a:ext>
             </a:extLst>
           </p:cNvPr>
@@ -5979,7 +5979,7 @@
     </p:spTree>
     <p:extLst>
       <p:ext uri="{BB962C8B-B14F-4D97-AF65-F5344CB8AC3E}">
-        <p14:creationId xmlns:p14="http://schemas.microsoft.com/office/powerpoint/2010/main" val="508915111"/>
+        <p14:creationId xmlns:p14="http://schemas.microsoft.com/office/powerpoint/2010/main" val="2098219131"/>
       </p:ext>
     </p:extLst>
   </p:cSld>
@@ -6010,7 +6010,7 @@
           <p:cNvPr id="11" name="">
             <a:extLst xmlns:a="http://schemas.openxmlformats.org/drawingml/2006/main">
               <a:ext uri="{FF2B5EF4-FFF2-40B4-BE49-F238E27FC236}">
-                <a16:creationId xmlns:a16="http://schemas.microsoft.com/office/drawing/2014/main" id="{2C3833B0-10F0-4EF4-8A2D-DEC6AF9CC7D1}"/>
+                <a16:creationId xmlns:a16="http://schemas.microsoft.com/office/drawing/2014/main" id="{07940F7E-D56C-4EAB-B7CF-BA76E8947167}"/>
               </a:ext>
             </a:extLst>
           </p:cNvPr>
@@ -6067,7 +6067,7 @@
           <p:cNvPr id="2" name="">
             <a:extLst xmlns:a="http://schemas.openxmlformats.org/drawingml/2006/main">
               <a:ext uri="{FF2B5EF4-FFF2-40B4-BE49-F238E27FC236}">
-                <a16:creationId xmlns:a16="http://schemas.microsoft.com/office/drawing/2014/main" id="{97CA5518-8EF7-4D50-B697-BE190CF775E0}"/>
+                <a16:creationId xmlns:a16="http://schemas.microsoft.com/office/drawing/2014/main" id="{C1F3AD8D-6919-48DD-AFD9-4BD5813FB59D}"/>
               </a:ext>
             </a:extLst>
           </p:cNvPr>
@@ -6124,7 +6124,7 @@
           <p:cNvPr id="3" name="">
             <a:extLst xmlns:a="http://schemas.openxmlformats.org/drawingml/2006/main">
               <a:ext uri="{FF2B5EF4-FFF2-40B4-BE49-F238E27FC236}">
-                <a16:creationId xmlns:a16="http://schemas.microsoft.com/office/drawing/2014/main" id="{A0B0BE6C-334C-477D-9B94-FC3256024059}"/>
+                <a16:creationId xmlns:a16="http://schemas.microsoft.com/office/drawing/2014/main" id="{5E7B5154-0610-4FD8-B506-A68362E63CEE}"/>
               </a:ext>
             </a:extLst>
           </p:cNvPr>
@@ -6181,7 +6181,7 @@
           <p:cNvPr id="4" name="">
             <a:extLst xmlns:a="http://schemas.openxmlformats.org/drawingml/2006/main">
               <a:ext uri="{FF2B5EF4-FFF2-40B4-BE49-F238E27FC236}">
-                <a16:creationId xmlns:a16="http://schemas.microsoft.com/office/drawing/2014/main" id="{129C5B3A-BFE1-4F76-BAD9-7A74F3E3D623}"/>
+                <a16:creationId xmlns:a16="http://schemas.microsoft.com/office/drawing/2014/main" id="{FE45D866-4E54-4F15-A737-CD4D352DEEFE}"/>
               </a:ext>
             </a:extLst>
           </p:cNvPr>
@@ -6238,7 +6238,7 @@
           <p:cNvPr id="5" name="">
             <a:extLst xmlns:a="http://schemas.openxmlformats.org/drawingml/2006/main">
               <a:ext uri="{FF2B5EF4-FFF2-40B4-BE49-F238E27FC236}">
-                <a16:creationId xmlns:a16="http://schemas.microsoft.com/office/drawing/2014/main" id="{8A85E10C-5400-42F2-B3EB-5A321FC34A22}"/>
+                <a16:creationId xmlns:a16="http://schemas.microsoft.com/office/drawing/2014/main" id="{5811B2BC-8A92-47C6-BD98-B5FE1CEDA5DB}"/>
               </a:ext>
             </a:extLst>
           </p:cNvPr>
@@ -6295,7 +6295,7 @@
           <p:cNvPr id="6" name="">
             <a:extLst xmlns:a="http://schemas.openxmlformats.org/drawingml/2006/main">
               <a:ext uri="{FF2B5EF4-FFF2-40B4-BE49-F238E27FC236}">
-                <a16:creationId xmlns:a16="http://schemas.microsoft.com/office/drawing/2014/main" id="{A0537999-CC32-4F4C-83CA-0C5A31929702}"/>
+                <a16:creationId xmlns:a16="http://schemas.microsoft.com/office/drawing/2014/main" id="{A341AC24-59A2-496E-98C5-9961EDF6FD22}"/>
               </a:ext>
             </a:extLst>
           </p:cNvPr>
@@ -6352,7 +6352,7 @@
           <p:cNvPr id="7" name="">
             <a:extLst xmlns:a="http://schemas.openxmlformats.org/drawingml/2006/main">
               <a:ext uri="{FF2B5EF4-FFF2-40B4-BE49-F238E27FC236}">
-                <a16:creationId xmlns:a16="http://schemas.microsoft.com/office/drawing/2014/main" id="{315D851A-7EE8-4075-94CC-EB4B19AFB322}"/>
+                <a16:creationId xmlns:a16="http://schemas.microsoft.com/office/drawing/2014/main" id="{42185BD1-8988-4336-895E-6B62596517EF}"/>
               </a:ext>
             </a:extLst>
           </p:cNvPr>
@@ -6409,7 +6409,7 @@
           <p:cNvPr id="8" name="">
             <a:extLst xmlns:a="http://schemas.openxmlformats.org/drawingml/2006/main">
               <a:ext uri="{FF2B5EF4-FFF2-40B4-BE49-F238E27FC236}">
-                <a16:creationId xmlns:a16="http://schemas.microsoft.com/office/drawing/2014/main" id="{3577C21E-2972-4A62-8455-B07FADA3B320}"/>
+                <a16:creationId xmlns:a16="http://schemas.microsoft.com/office/drawing/2014/main" id="{D1B76537-6B74-49E2-BB24-AF01A2239092}"/>
               </a:ext>
             </a:extLst>
           </p:cNvPr>
@@ -6466,7 +6466,7 @@
           <p:cNvPr id="9" name="">
             <a:extLst xmlns:a="http://schemas.openxmlformats.org/drawingml/2006/main">
               <a:ext uri="{FF2B5EF4-FFF2-40B4-BE49-F238E27FC236}">
-                <a16:creationId xmlns:a16="http://schemas.microsoft.com/office/drawing/2014/main" id="{47586CC6-3A98-42B5-9234-EF5780DEBA52}"/>
+                <a16:creationId xmlns:a16="http://schemas.microsoft.com/office/drawing/2014/main" id="{AE8A4200-1547-4E1E-81DB-E322394445E1}"/>
               </a:ext>
             </a:extLst>
           </p:cNvPr>
@@ -6523,7 +6523,7 @@
           <p:cNvPr id="10" name="">
             <a:extLst xmlns:a="http://schemas.openxmlformats.org/drawingml/2006/main">
               <a:ext uri="{FF2B5EF4-FFF2-40B4-BE49-F238E27FC236}">
-                <a16:creationId xmlns:a16="http://schemas.microsoft.com/office/drawing/2014/main" id="{3151C3AA-7F6A-4147-AA15-64CE2D8BF77C}"/>
+                <a16:creationId xmlns:a16="http://schemas.microsoft.com/office/drawing/2014/main" id="{A674A2CB-0C7C-4DBC-B31B-F7B01889C3B4}"/>
               </a:ext>
             </a:extLst>
           </p:cNvPr>
@@ -6570,7 +6570,7 @@
                 <a:ea typeface="Arial"/>
                 <a:cs typeface="Arial"/>
               </a:rPr>
-              <a:t>The final application shows the six recovered IDs and DR-TEST in Ready status.</a:t>
+              <a:t>The final app shows six recovered IDs and DR-TEST Ready. Closeout checks confirmed health and integrity ok.</a:t>
             </a:r>
           </a:p>
         </p:txBody>
@@ -6578,7 +6578,7 @@
     </p:spTree>
     <p:extLst>
       <p:ext uri="{BB962C8B-B14F-4D97-AF65-F5344CB8AC3E}">
-        <p14:creationId xmlns:p14="http://schemas.microsoft.com/office/powerpoint/2010/main" val="1444005653"/>
+        <p14:creationId xmlns:p14="http://schemas.microsoft.com/office/powerpoint/2010/main" val="1793973953"/>
       </p:ext>
     </p:extLst>
   </p:cSld>
@@ -6609,7 +6609,7 @@
           <p:cNvPr id="7" name="">
             <a:extLst xmlns:a="http://schemas.openxmlformats.org/drawingml/2006/main">
               <a:ext uri="{FF2B5EF4-FFF2-40B4-BE49-F238E27FC236}">
-                <a16:creationId xmlns:a16="http://schemas.microsoft.com/office/drawing/2014/main" id="{BD0F84BC-0CE0-48CF-942F-1E532F5C5A94}"/>
+                <a16:creationId xmlns:a16="http://schemas.microsoft.com/office/drawing/2014/main" id="{21314A4A-A2B2-40AF-B8D1-EF985C73D488}"/>
               </a:ext>
             </a:extLst>
           </p:cNvPr>
@@ -6666,7 +6666,7 @@
           <p:cNvPr id="2" name="">
             <a:extLst xmlns:a="http://schemas.openxmlformats.org/drawingml/2006/main">
               <a:ext uri="{FF2B5EF4-FFF2-40B4-BE49-F238E27FC236}">
-                <a16:creationId xmlns:a16="http://schemas.microsoft.com/office/drawing/2014/main" id="{68406403-A679-498A-B8AF-176CB7DF44F9}"/>
+                <a16:creationId xmlns:a16="http://schemas.microsoft.com/office/drawing/2014/main" id="{27958004-15AF-4CAB-A4E5-3061559056AF}"/>
               </a:ext>
             </a:extLst>
           </p:cNvPr>
@@ -6723,7 +6723,7 @@
           <p:cNvPr id="3" name="">
             <a:extLst xmlns:a="http://schemas.openxmlformats.org/drawingml/2006/main">
               <a:ext uri="{FF2B5EF4-FFF2-40B4-BE49-F238E27FC236}">
-                <a16:creationId xmlns:a16="http://schemas.microsoft.com/office/drawing/2014/main" id="{21AB1F12-DAF0-4713-BCC1-4F00CEAB4A6A}"/>
+                <a16:creationId xmlns:a16="http://schemas.microsoft.com/office/drawing/2014/main" id="{2B253168-B177-450B-92E4-880DD6D0D845}"/>
               </a:ext>
             </a:extLst>
           </p:cNvPr>
@@ -6780,7 +6780,7 @@
           <p:cNvPr id="4" name="">
             <a:extLst xmlns:a="http://schemas.openxmlformats.org/drawingml/2006/main">
               <a:ext uri="{FF2B5EF4-FFF2-40B4-BE49-F238E27FC236}">
-                <a16:creationId xmlns:a16="http://schemas.microsoft.com/office/drawing/2014/main" id="{06730470-12FF-457E-A30C-3DD1FD2E9855}"/>
+                <a16:creationId xmlns:a16="http://schemas.microsoft.com/office/drawing/2014/main" id="{E8AB1991-CFFA-43B8-9AE0-17E0FA83BF65}"/>
               </a:ext>
             </a:extLst>
           </p:cNvPr>
@@ -6841,7 +6841,7 @@
           <p:nvPr/>
         </p:nvPicPr>
         <p:blipFill>
-          <a:blip xmlns:r="http://schemas.openxmlformats.org/officeDocument/2006/relationships" xmlns:a="http://schemas.openxmlformats.org/drawingml/2006/main" r:embed="R97383f60faac452f"/>
+          <a:blip xmlns:r="http://schemas.openxmlformats.org/officeDocument/2006/relationships" xmlns:a="http://schemas.openxmlformats.org/drawingml/2006/main" r:embed="R32b10955897c4c08"/>
           <a:stretch xmlns:a="http://schemas.openxmlformats.org/drawingml/2006/main"/>
         </p:blipFill>
         <p:spPr>
@@ -6859,7 +6859,7 @@
           <p:cNvPr id="6" name="">
             <a:extLst xmlns:a="http://schemas.openxmlformats.org/drawingml/2006/main">
               <a:ext uri="{FF2B5EF4-FFF2-40B4-BE49-F238E27FC236}">
-                <a16:creationId xmlns:a16="http://schemas.microsoft.com/office/drawing/2014/main" id="{FF61C94B-24A9-40D0-ACBF-1BF36D1BB611}"/>
+                <a16:creationId xmlns:a16="http://schemas.microsoft.com/office/drawing/2014/main" id="{C0B4F6FF-3B28-471E-A557-849F97182D73}"/>
               </a:ext>
             </a:extLst>
           </p:cNvPr>
@@ -6914,7 +6914,7 @@
     </p:spTree>
     <p:extLst>
       <p:ext uri="{BB962C8B-B14F-4D97-AF65-F5344CB8AC3E}">
-        <p14:creationId xmlns:p14="http://schemas.microsoft.com/office/powerpoint/2010/main" val="1029337833"/>
+        <p14:creationId xmlns:p14="http://schemas.microsoft.com/office/powerpoint/2010/main" val="512573970"/>
       </p:ext>
     </p:extLst>
   </p:cSld>
@@ -6945,7 +6945,7 @@
           <p:cNvPr id="10" name="">
             <a:extLst xmlns:a="http://schemas.openxmlformats.org/drawingml/2006/main">
               <a:ext uri="{FF2B5EF4-FFF2-40B4-BE49-F238E27FC236}">
-                <a16:creationId xmlns:a16="http://schemas.microsoft.com/office/drawing/2014/main" id="{2F68062A-BEFE-4D83-989C-517853DC8493}"/>
+                <a16:creationId xmlns:a16="http://schemas.microsoft.com/office/drawing/2014/main" id="{55F561F7-72EE-417F-BF94-88AB06966792}"/>
               </a:ext>
             </a:extLst>
           </p:cNvPr>
@@ -7002,7 +7002,7 @@
           <p:cNvPr id="2" name="">
             <a:extLst xmlns:a="http://schemas.openxmlformats.org/drawingml/2006/main">
               <a:ext uri="{FF2B5EF4-FFF2-40B4-BE49-F238E27FC236}">
-                <a16:creationId xmlns:a16="http://schemas.microsoft.com/office/drawing/2014/main" id="{C282A6AB-8888-45FE-8237-3B3E8035F463}"/>
+                <a16:creationId xmlns:a16="http://schemas.microsoft.com/office/drawing/2014/main" id="{4154CA78-03A7-4732-B6E6-85D82BC1E4D9}"/>
               </a:ext>
             </a:extLst>
           </p:cNvPr>
@@ -7059,7 +7059,7 @@
           <p:cNvPr id="3" name="">
             <a:extLst xmlns:a="http://schemas.openxmlformats.org/drawingml/2006/main">
               <a:ext uri="{FF2B5EF4-FFF2-40B4-BE49-F238E27FC236}">
-                <a16:creationId xmlns:a16="http://schemas.microsoft.com/office/drawing/2014/main" id="{59607DD7-9D95-4FF0-A3C5-CA27B51CE9D0}"/>
+                <a16:creationId xmlns:a16="http://schemas.microsoft.com/office/drawing/2014/main" id="{B4E92CE7-CE1B-4A2C-A25C-00CA5DEEFC2E}"/>
               </a:ext>
             </a:extLst>
           </p:cNvPr>
@@ -7116,7 +7116,7 @@
           <p:cNvPr id="4" name="">
             <a:extLst xmlns:a="http://schemas.openxmlformats.org/drawingml/2006/main">
               <a:ext uri="{FF2B5EF4-FFF2-40B4-BE49-F238E27FC236}">
-                <a16:creationId xmlns:a16="http://schemas.microsoft.com/office/drawing/2014/main" id="{B726364F-A8AB-40BB-A80F-B97CE1944E49}"/>
+                <a16:creationId xmlns:a16="http://schemas.microsoft.com/office/drawing/2014/main" id="{9343C166-EDEF-4A53-9383-0375E21E86C9}"/>
               </a:ext>
             </a:extLst>
           </p:cNvPr>
@@ -7173,7 +7173,7 @@
           <p:cNvPr id="5" name="">
             <a:extLst xmlns:a="http://schemas.openxmlformats.org/drawingml/2006/main">
               <a:ext uri="{FF2B5EF4-FFF2-40B4-BE49-F238E27FC236}">
-                <a16:creationId xmlns:a16="http://schemas.microsoft.com/office/drawing/2014/main" id="{AFA6C88E-AE73-41F1-A547-DD9A61CEA8F8}"/>
+                <a16:creationId xmlns:a16="http://schemas.microsoft.com/office/drawing/2014/main" id="{FDD574C0-33EB-4BA7-AA9A-BE601A4F8023}"/>
               </a:ext>
             </a:extLst>
           </p:cNvPr>
@@ -7230,7 +7230,7 @@
           <p:cNvPr id="6" name="">
             <a:extLst xmlns:a="http://schemas.openxmlformats.org/drawingml/2006/main">
               <a:ext uri="{FF2B5EF4-FFF2-40B4-BE49-F238E27FC236}">
-                <a16:creationId xmlns:a16="http://schemas.microsoft.com/office/drawing/2014/main" id="{5EDF022E-B450-4D97-A8E1-BA5856CB2456}"/>
+                <a16:creationId xmlns:a16="http://schemas.microsoft.com/office/drawing/2014/main" id="{6C816DD9-3ECE-4778-8BA7-1EDA8E0D0ED9}"/>
               </a:ext>
             </a:extLst>
           </p:cNvPr>
@@ -7287,7 +7287,7 @@
           <p:cNvPr id="7" name="">
             <a:extLst xmlns:a="http://schemas.openxmlformats.org/drawingml/2006/main">
               <a:ext uri="{FF2B5EF4-FFF2-40B4-BE49-F238E27FC236}">
-                <a16:creationId xmlns:a16="http://schemas.microsoft.com/office/drawing/2014/main" id="{826BC852-7E84-4D02-ADC2-A8507C408122}"/>
+                <a16:creationId xmlns:a16="http://schemas.microsoft.com/office/drawing/2014/main" id="{E152B0B0-0226-4218-A38B-612B63F5DDCA}"/>
               </a:ext>
             </a:extLst>
           </p:cNvPr>
@@ -7344,7 +7344,7 @@
           <p:cNvPr id="8" name="">
             <a:extLst xmlns:a="http://schemas.openxmlformats.org/drawingml/2006/main">
               <a:ext uri="{FF2B5EF4-FFF2-40B4-BE49-F238E27FC236}">
-                <a16:creationId xmlns:a16="http://schemas.microsoft.com/office/drawing/2014/main" id="{997B0711-8C5D-4F03-B336-248260E1F232}"/>
+                <a16:creationId xmlns:a16="http://schemas.microsoft.com/office/drawing/2014/main" id="{2A9BFEF8-36AF-4AF1-8476-AF0A47B56579}"/>
               </a:ext>
             </a:extLst>
           </p:cNvPr>
@@ -7401,7 +7401,7 @@
           <p:cNvPr id="9" name="">
             <a:extLst xmlns:a="http://schemas.openxmlformats.org/drawingml/2006/main">
               <a:ext uri="{FF2B5EF4-FFF2-40B4-BE49-F238E27FC236}">
-                <a16:creationId xmlns:a16="http://schemas.microsoft.com/office/drawing/2014/main" id="{F50E5031-6109-4275-A658-BE33B376E3A0}"/>
+                <a16:creationId xmlns:a16="http://schemas.microsoft.com/office/drawing/2014/main" id="{C32FE846-7E29-4DF0-AA28-8DDF9536ED17}"/>
               </a:ext>
             </a:extLst>
           </p:cNvPr>
@@ -7456,7 +7456,7 @@
     </p:spTree>
     <p:extLst>
       <p:ext uri="{BB962C8B-B14F-4D97-AF65-F5344CB8AC3E}">
-        <p14:creationId xmlns:p14="http://schemas.microsoft.com/office/powerpoint/2010/main" val="1007762094"/>
+        <p14:creationId xmlns:p14="http://schemas.microsoft.com/office/powerpoint/2010/main" val="1382769995"/>
       </p:ext>
     </p:extLst>
   </p:cSld>
@@ -7487,7 +7487,7 @@
           <p:cNvPr id="8" name="">
             <a:extLst xmlns:a="http://schemas.openxmlformats.org/drawingml/2006/main">
               <a:ext uri="{FF2B5EF4-FFF2-40B4-BE49-F238E27FC236}">
-                <a16:creationId xmlns:a16="http://schemas.microsoft.com/office/drawing/2014/main" id="{02A767E1-3DEC-4D86-9AE2-ECC1B12A93BC}"/>
+                <a16:creationId xmlns:a16="http://schemas.microsoft.com/office/drawing/2014/main" id="{39FB5335-6DE6-4849-A02C-36D1DBFE5DF7}"/>
               </a:ext>
             </a:extLst>
           </p:cNvPr>
@@ -7544,7 +7544,7 @@
           <p:cNvPr id="2" name="">
             <a:extLst xmlns:a="http://schemas.openxmlformats.org/drawingml/2006/main">
               <a:ext uri="{FF2B5EF4-FFF2-40B4-BE49-F238E27FC236}">
-                <a16:creationId xmlns:a16="http://schemas.microsoft.com/office/drawing/2014/main" id="{BABE55E7-0455-416F-BBD9-95A6C83459AE}"/>
+                <a16:creationId xmlns:a16="http://schemas.microsoft.com/office/drawing/2014/main" id="{29C7C59D-63AC-4B2C-8901-FAF2A5ED06AF}"/>
               </a:ext>
             </a:extLst>
           </p:cNvPr>
@@ -7601,7 +7601,7 @@
           <p:cNvPr id="3" name="">
             <a:extLst xmlns:a="http://schemas.openxmlformats.org/drawingml/2006/main">
               <a:ext uri="{FF2B5EF4-FFF2-40B4-BE49-F238E27FC236}">
-                <a16:creationId xmlns:a16="http://schemas.microsoft.com/office/drawing/2014/main" id="{FDDECCC7-E097-4C8D-90C1-DB5915DBDD2D}"/>
+                <a16:creationId xmlns:a16="http://schemas.microsoft.com/office/drawing/2014/main" id="{EC9DE025-F8F4-434A-A369-CBF4EEB93BAE}"/>
               </a:ext>
             </a:extLst>
           </p:cNvPr>
@@ -7658,7 +7658,7 @@
           <p:cNvPr id="4" name="">
             <a:extLst xmlns:a="http://schemas.openxmlformats.org/drawingml/2006/main">
               <a:ext uri="{FF2B5EF4-FFF2-40B4-BE49-F238E27FC236}">
-                <a16:creationId xmlns:a16="http://schemas.microsoft.com/office/drawing/2014/main" id="{C0FF92A1-ABF6-4756-95C7-E79E36BDA2A2}"/>
+                <a16:creationId xmlns:a16="http://schemas.microsoft.com/office/drawing/2014/main" id="{9E5F0607-5601-4549-8738-A2753200644D}"/>
               </a:ext>
             </a:extLst>
           </p:cNvPr>
@@ -7719,7 +7719,7 @@
           <p:nvPr/>
         </p:nvPicPr>
         <p:blipFill>
-          <a:blip xmlns:r="http://schemas.openxmlformats.org/officeDocument/2006/relationships" xmlns:a="http://schemas.openxmlformats.org/drawingml/2006/main" r:embed="Rea04434b66a741b7"/>
+          <a:blip xmlns:r="http://schemas.openxmlformats.org/officeDocument/2006/relationships" xmlns:a="http://schemas.openxmlformats.org/drawingml/2006/main" r:embed="R71a4ea6bd0904635"/>
           <a:stretch xmlns:a="http://schemas.openxmlformats.org/drawingml/2006/main"/>
         </p:blipFill>
         <p:spPr>
@@ -7737,7 +7737,7 @@
           <p:cNvPr id="6" name="">
             <a:extLst xmlns:a="http://schemas.openxmlformats.org/drawingml/2006/main">
               <a:ext uri="{FF2B5EF4-FFF2-40B4-BE49-F238E27FC236}">
-                <a16:creationId xmlns:a16="http://schemas.microsoft.com/office/drawing/2014/main" id="{5CB95707-BA79-4E30-9442-F806AC5EC499}"/>
+                <a16:creationId xmlns:a16="http://schemas.microsoft.com/office/drawing/2014/main" id="{5B32A960-0A69-445A-86E9-9A12EEE7EF15}"/>
               </a:ext>
             </a:extLst>
           </p:cNvPr>
@@ -7794,7 +7794,7 @@
           <p:cNvPr id="7" name="">
             <a:extLst xmlns:a="http://schemas.openxmlformats.org/drawingml/2006/main">
               <a:ext uri="{FF2B5EF4-FFF2-40B4-BE49-F238E27FC236}">
-                <a16:creationId xmlns:a16="http://schemas.microsoft.com/office/drawing/2014/main" id="{3F220876-F44D-4508-9C09-39F7B445BA52}"/>
+                <a16:creationId xmlns:a16="http://schemas.microsoft.com/office/drawing/2014/main" id="{1243332F-3056-4DC1-B1FE-2EE9D1BC4987}"/>
               </a:ext>
             </a:extLst>
           </p:cNvPr>
@@ -7849,7 +7849,7 @@
     </p:spTree>
     <p:extLst>
       <p:ext uri="{BB962C8B-B14F-4D97-AF65-F5344CB8AC3E}">
-        <p14:creationId xmlns:p14="http://schemas.microsoft.com/office/powerpoint/2010/main" val="1403785893"/>
+        <p14:creationId xmlns:p14="http://schemas.microsoft.com/office/powerpoint/2010/main" val="1485954856"/>
       </p:ext>
     </p:extLst>
   </p:cSld>

</xml_diff>